<commit_message>
docs: add official hackathon presentation to dedicated ppt/ directory and document in README.md
</commit_message>
<xml_diff>
--- a/frontend/public/VTU-QFF-HC-079.pptx
+++ b/frontend/public/VTU-QFF-HC-079.pptx
@@ -1,30 +1,30 @@
 
 <file path=ppt/presentation.xml><?xml version="1.0" encoding="utf-8"?>
-<p:presentation xmlns:a="http://schemas.openxmlformats.org/drawingml/2006/main" xmlns:r="http://schemas.openxmlformats.org/officeDocument/2006/relationships" xmlns:mc="http://schemas.openxmlformats.org/markup-compatibility/2006" xmlns:mv="urn:schemas-microsoft-com:mac:vml" xmlns:p="http://schemas.openxmlformats.org/presentationml/2006/main" xmlns:c="http://schemas.openxmlformats.org/drawingml/2006/chart" xmlns:dgm="http://schemas.openxmlformats.org/drawingml/2006/diagram" xmlns:o="urn:schemas-microsoft-com:office:office" xmlns:v="urn:schemas-microsoft-com:vml" xmlns:pvml="urn:schemas-microsoft-com:office:powerpoint" xmlns:com="http://schemas.openxmlformats.org/drawingml/2006/compatibility" xmlns:p14="http://schemas.microsoft.com/office/powerpoint/2010/main" xmlns:p15="http://schemas.microsoft.com/office/powerpoint/2012/main" xmlns:ahyp="http://schemas.microsoft.com/office/drawing/2018/hyperlinkcolor" autoCompressPictures="0" strictFirstAndLastChars="0" saveSubsetFonts="1">
+<p:presentation xmlns:a="http://schemas.openxmlformats.org/drawingml/2006/main" xmlns:r="http://schemas.openxmlformats.org/officeDocument/2006/relationships" xmlns:p="http://schemas.openxmlformats.org/presentationml/2006/main" strictFirstAndLastChars="0" saveSubsetFonts="1" autoCompressPictures="0">
   <p:sldMasterIdLst>
-    <p:sldMasterId id="2147483648" r:id="rId3"/>
+    <p:sldMasterId id="2147483648" r:id="rId1"/>
   </p:sldMasterIdLst>
   <p:notesMasterIdLst>
-    <p:notesMasterId r:id="rId4"/>
+    <p:notesMasterId r:id="rId12"/>
   </p:notesMasterIdLst>
   <p:sldIdLst>
-    <p:sldId id="256" r:id="rId5"/>
-    <p:sldId id="257" r:id="rId6"/>
-    <p:sldId id="258" r:id="rId7"/>
-    <p:sldId id="259" r:id="rId8"/>
-    <p:sldId id="260" r:id="rId9"/>
-    <p:sldId id="261" r:id="rId10"/>
-    <p:sldId id="262" r:id="rId11"/>
-    <p:sldId id="263" r:id="rId12"/>
-    <p:sldId id="264" r:id="rId13"/>
-    <p:sldId id="265" r:id="rId14"/>
+    <p:sldId id="256" r:id="rId2"/>
+    <p:sldId id="257" r:id="rId3"/>
+    <p:sldId id="258" r:id="rId4"/>
+    <p:sldId id="259" r:id="rId5"/>
+    <p:sldId id="260" r:id="rId6"/>
+    <p:sldId id="261" r:id="rId7"/>
+    <p:sldId id="262" r:id="rId8"/>
+    <p:sldId id="263" r:id="rId9"/>
+    <p:sldId id="264" r:id="rId10"/>
+    <p:sldId id="265" r:id="rId11"/>
   </p:sldIdLst>
-  <p:sldSz cy="5143500" cx="9144000"/>
+  <p:sldSz cx="9144000" cy="5143500" type="screen16x9"/>
   <p:notesSz cx="5143500" cy="9144000"/>
   <p:defaultTextStyle>
     <a:defPPr lvl="0"/>
-    <a:lvl1pPr defTabSz="914400" eaLnBrk="1" hangingPunct="1" latinLnBrk="0" lvl="0" marL="0" rtl="0" algn="l">
-      <a:defRPr kern="1200" sz="1800">
+    <a:lvl1pPr marL="0" lvl="0" algn="l" defTabSz="914400" rtl="0" eaLnBrk="1" latinLnBrk="0" hangingPunct="1">
+      <a:defRPr sz="1800" kern="1200">
         <a:solidFill>
           <a:schemeClr val="tx1"/>
         </a:solidFill>
@@ -33,8 +33,8 @@
         <a:cs typeface="+mn-cs"/>
       </a:defRPr>
     </a:lvl1pPr>
-    <a:lvl2pPr defTabSz="914400" eaLnBrk="1" hangingPunct="1" latinLnBrk="0" lvl="1" marL="457200" rtl="0" algn="l">
-      <a:defRPr kern="1200" sz="1800">
+    <a:lvl2pPr marL="457200" lvl="1" algn="l" defTabSz="914400" rtl="0" eaLnBrk="1" latinLnBrk="0" hangingPunct="1">
+      <a:defRPr sz="1800" kern="1200">
         <a:solidFill>
           <a:schemeClr val="tx1"/>
         </a:solidFill>
@@ -43,8 +43,8 @@
         <a:cs typeface="+mn-cs"/>
       </a:defRPr>
     </a:lvl2pPr>
-    <a:lvl3pPr defTabSz="914400" eaLnBrk="1" hangingPunct="1" latinLnBrk="0" lvl="2" marL="914400" rtl="0" algn="l">
-      <a:defRPr kern="1200" sz="1800">
+    <a:lvl3pPr marL="914400" lvl="2" algn="l" defTabSz="914400" rtl="0" eaLnBrk="1" latinLnBrk="0" hangingPunct="1">
+      <a:defRPr sz="1800" kern="1200">
         <a:solidFill>
           <a:schemeClr val="tx1"/>
         </a:solidFill>
@@ -53,8 +53,8 @@
         <a:cs typeface="+mn-cs"/>
       </a:defRPr>
     </a:lvl3pPr>
-    <a:lvl4pPr defTabSz="914400" eaLnBrk="1" hangingPunct="1" latinLnBrk="0" lvl="3" marL="1371600" rtl="0" algn="l">
-      <a:defRPr kern="1200" sz="1800">
+    <a:lvl4pPr marL="1371600" lvl="3" algn="l" defTabSz="914400" rtl="0" eaLnBrk="1" latinLnBrk="0" hangingPunct="1">
+      <a:defRPr sz="1800" kern="1200">
         <a:solidFill>
           <a:schemeClr val="tx1"/>
         </a:solidFill>
@@ -63,8 +63,8 @@
         <a:cs typeface="+mn-cs"/>
       </a:defRPr>
     </a:lvl4pPr>
-    <a:lvl5pPr defTabSz="914400" eaLnBrk="1" hangingPunct="1" latinLnBrk="0" lvl="4" marL="1828800" rtl="0" algn="l">
-      <a:defRPr kern="1200" sz="1800">
+    <a:lvl5pPr marL="1828800" lvl="4" algn="l" defTabSz="914400" rtl="0" eaLnBrk="1" latinLnBrk="0" hangingPunct="1">
+      <a:defRPr sz="1800" kern="1200">
         <a:solidFill>
           <a:schemeClr val="tx1"/>
         </a:solidFill>
@@ -73,8 +73,8 @@
         <a:cs typeface="+mn-cs"/>
       </a:defRPr>
     </a:lvl5pPr>
-    <a:lvl6pPr defTabSz="914400" eaLnBrk="1" hangingPunct="1" latinLnBrk="0" lvl="5" marL="2286000" rtl="0" algn="l">
-      <a:defRPr kern="1200" sz="1800">
+    <a:lvl6pPr marL="2286000" lvl="5" algn="l" defTabSz="914400" rtl="0" eaLnBrk="1" latinLnBrk="0" hangingPunct="1">
+      <a:defRPr sz="1800" kern="1200">
         <a:solidFill>
           <a:schemeClr val="tx1"/>
         </a:solidFill>
@@ -83,8 +83,8 @@
         <a:cs typeface="+mn-cs"/>
       </a:defRPr>
     </a:lvl6pPr>
-    <a:lvl7pPr defTabSz="914400" eaLnBrk="1" hangingPunct="1" latinLnBrk="0" lvl="6" marL="2743200" rtl="0" algn="l">
-      <a:defRPr kern="1200" sz="1800">
+    <a:lvl7pPr marL="2743200" lvl="6" algn="l" defTabSz="914400" rtl="0" eaLnBrk="1" latinLnBrk="0" hangingPunct="1">
+      <a:defRPr sz="1800" kern="1200">
         <a:solidFill>
           <a:schemeClr val="tx1"/>
         </a:solidFill>
@@ -93,8 +93,8 @@
         <a:cs typeface="+mn-cs"/>
       </a:defRPr>
     </a:lvl7pPr>
-    <a:lvl8pPr defTabSz="914400" eaLnBrk="1" hangingPunct="1" latinLnBrk="0" lvl="7" marL="3200400" rtl="0" algn="l">
-      <a:defRPr kern="1200" sz="1800">
+    <a:lvl8pPr marL="3200400" lvl="7" algn="l" defTabSz="914400" rtl="0" eaLnBrk="1" latinLnBrk="0" hangingPunct="1">
+      <a:defRPr sz="1800" kern="1200">
         <a:solidFill>
           <a:schemeClr val="tx1"/>
         </a:solidFill>
@@ -103,8 +103,8 @@
         <a:cs typeface="+mn-cs"/>
       </a:defRPr>
     </a:lvl8pPr>
-    <a:lvl9pPr defTabSz="914400" eaLnBrk="1" hangingPunct="1" latinLnBrk="0" lvl="8" marL="3657600" rtl="0" algn="l">
-      <a:defRPr kern="1200" sz="1800">
+    <a:lvl9pPr marL="3657600" lvl="8" algn="l" defTabSz="914400" rtl="0" eaLnBrk="1" latinLnBrk="0" hangingPunct="1">
+      <a:defRPr sz="1800" kern="1200">
         <a:solidFill>
           <a:schemeClr val="tx1"/>
         </a:solidFill>
@@ -115,10 +115,6 @@
     </a:lvl9pPr>
   </p:defaultTextStyle>
 </p:presentation>
-</file>
-
-<file path=ppt/presProps1.xml><?xml version="1.0" encoding="utf-8"?>
-<p:presentationPr xmlns:a="http://schemas.openxmlformats.org/drawingml/2006/main" xmlns:r="http://schemas.openxmlformats.org/officeDocument/2006/relationships" xmlns:mc="http://schemas.openxmlformats.org/markup-compatibility/2006" xmlns:mv="urn:schemas-microsoft-com:mac:vml" xmlns:p="http://schemas.openxmlformats.org/presentationml/2006/main" xmlns:c="http://schemas.openxmlformats.org/drawingml/2006/chart" xmlns:dgm="http://schemas.openxmlformats.org/drawingml/2006/diagram" xmlns:o="urn:schemas-microsoft-com:office:office" xmlns:v="urn:schemas-microsoft-com:vml" xmlns:pvml="urn:schemas-microsoft-com:office:powerpoint" xmlns:com="http://schemas.openxmlformats.org/drawingml/2006/compatibility" xmlns:p14="http://schemas.microsoft.com/office/powerpoint/2010/main" xmlns:p15="http://schemas.microsoft.com/office/powerpoint/2012/main" xmlns:ahyp="http://schemas.microsoft.com/office/drawing/2018/hyperlinkcolor"/>
 </file>
 
 <file path=ppt/notesMasters/notesMaster1.xml><?xml version="1.0" encoding="utf-8"?>
@@ -203,7 +199,7 @@
           <a:p>
             <a:fld id="{2EFA1F8C-B10B-C84D-94FC-B3DA01C1C208}" type="datetimeFigureOut">
               <a:rPr lang="en-US" smtClean="0"/>
-              <a:t>10/22/2026</a:t>
+              <a:t>10/23/2026</a:t>
             </a:fld>
             <a:endParaRPr lang="en-US"/>
           </a:p>
@@ -1389,6 +1385,13 @@
             <a:prstDash val="solid"/>
           </a:ln>
         </p:spPr>
+        <p:txBody>
+          <a:bodyPr/>
+          <a:lstStyle/>
+          <a:p>
+            <a:endParaRPr lang="en-IN"/>
+          </a:p>
+        </p:txBody>
       </p:sp>
       <p:sp>
         <p:nvSpPr>
@@ -1414,6 +1417,13 @@
             <a:prstDash val="solid"/>
           </a:ln>
         </p:spPr>
+        <p:txBody>
+          <a:bodyPr/>
+          <a:lstStyle/>
+          <a:p>
+            <a:endParaRPr lang="en-IN"/>
+          </a:p>
+        </p:txBody>
       </p:sp>
       <p:sp>
         <p:nvSpPr>
@@ -1439,6 +1449,13 @@
             <a:prstDash val="solid"/>
           </a:ln>
         </p:spPr>
+        <p:txBody>
+          <a:bodyPr/>
+          <a:lstStyle/>
+          <a:p>
+            <a:endParaRPr lang="en-IN"/>
+          </a:p>
+        </p:txBody>
       </p:sp>
       <p:sp>
         <p:nvSpPr>
@@ -1464,6 +1481,13 @@
             <a:prstDash val="solid"/>
           </a:ln>
         </p:spPr>
+        <p:txBody>
+          <a:bodyPr/>
+          <a:lstStyle/>
+          <a:p>
+            <a:endParaRPr lang="en-IN"/>
+          </a:p>
+        </p:txBody>
       </p:sp>
       <p:pic>
         <p:nvPicPr>
@@ -1711,6 +1735,13 @@
             <a:prstDash val="solid"/>
           </a:ln>
         </p:spPr>
+        <p:txBody>
+          <a:bodyPr/>
+          <a:lstStyle/>
+          <a:p>
+            <a:endParaRPr lang="en-IN"/>
+          </a:p>
+        </p:txBody>
       </p:sp>
       <p:sp>
         <p:nvSpPr>
@@ -1736,6 +1767,13 @@
             <a:prstDash val="solid"/>
           </a:ln>
         </p:spPr>
+        <p:txBody>
+          <a:bodyPr/>
+          <a:lstStyle/>
+          <a:p>
+            <a:endParaRPr lang="en-IN"/>
+          </a:p>
+        </p:txBody>
       </p:sp>
       <p:sp>
         <p:nvSpPr>
@@ -1761,6 +1799,13 @@
             <a:prstDash val="solid"/>
           </a:ln>
         </p:spPr>
+        <p:txBody>
+          <a:bodyPr/>
+          <a:lstStyle/>
+          <a:p>
+            <a:endParaRPr lang="en-IN"/>
+          </a:p>
+        </p:txBody>
       </p:sp>
       <p:sp>
         <p:nvSpPr>
@@ -1786,6 +1831,13 @@
             <a:prstDash val="solid"/>
           </a:ln>
         </p:spPr>
+        <p:txBody>
+          <a:bodyPr/>
+          <a:lstStyle/>
+          <a:p>
+            <a:endParaRPr lang="en-IN"/>
+          </a:p>
+        </p:txBody>
       </p:sp>
       <p:sp>
         <p:nvSpPr>
@@ -2522,7 +2574,7 @@
           </a:prstGeom>
           <a:extLst>
             <a:ext uri="{C572A759-6A51-4108-AA02-DFA0A04FC94B}">
-              <ma14:wrappingTextBoxFlag xmlns:ma14="http://schemas.microsoft.com/office/mac/drawingml/2011/main" xmlns="" val="0"/>
+              <ma14:wrappingTextBoxFlag xmlns="" xmlns:ma14="http://schemas.microsoft.com/office/mac/drawingml/2011/main" val="0"/>
             </a:ext>
           </a:extLst>
         </p:spPr>
@@ -2597,7 +2649,7 @@
           </a:prstGeom>
           <a:extLst>
             <a:ext uri="{C572A759-6A51-4108-AA02-DFA0A04FC94B}">
-              <ma14:wrappingTextBoxFlag xmlns:ma14="http://schemas.microsoft.com/office/mac/drawingml/2011/main" xmlns="" val="0"/>
+              <ma14:wrappingTextBoxFlag xmlns="" xmlns:ma14="http://schemas.microsoft.com/office/mac/drawingml/2011/main" val="0"/>
             </a:ext>
           </a:extLst>
         </p:spPr>
@@ -3299,7 +3351,7 @@
               <a:buNone/>
             </a:pPr>
             <a:r>
-              <a:rPr sz="1100" b="1">
+              <a:rPr sz="1100" b="1" dirty="0">
                 <a:solidFill>
                   <a:srgbClr val="2A2A38"/>
                 </a:solidFill>
@@ -3423,13 +3475,22 @@
               <a:buNone/>
             </a:pPr>
             <a:r>
-              <a:rPr sz="1100" b="1">
+              <a:rPr lang="en-US" sz="1100" b="1" dirty="0">
                 <a:solidFill>
                   <a:srgbClr val="2A2A38"/>
                 </a:solidFill>
                 <a:latin typeface="Calibri"/>
               </a:rPr>
-              <a:t>DualQ Technical Lead</a:t>
+              <a:t>Arun </a:t>
+            </a:r>
+            <a:r>
+              <a:rPr lang="en-US" sz="1100" b="1" dirty="0" err="1">
+                <a:solidFill>
+                  <a:srgbClr val="2A2A38"/>
+                </a:solidFill>
+                <a:latin typeface="Calibri"/>
+              </a:rPr>
+              <a:t>HIkadi</a:t>
             </a:r>
             <a:endParaRPr lang="en-US" sz="900" dirty="0"/>
           </a:p>
@@ -3485,13 +3546,13 @@
               <a:buNone/>
             </a:pPr>
             <a:r>
-              <a:rPr sz="1100" b="1">
+              <a:rPr lang="en-US" sz="1100" b="1" dirty="0">
                 <a:solidFill>
                   <a:srgbClr val="2A2A38"/>
                 </a:solidFill>
                 <a:latin typeface="Calibri"/>
               </a:rPr>
-              <a:t>team@dualq.internal</a:t>
+              <a:t>hikadiarun2221@gmail.com</a:t>
             </a:r>
             <a:endParaRPr lang="en-US" sz="900" dirty="0"/>
           </a:p>
@@ -3543,18 +3604,55 @@
             <a:endParaRPr lang="en-US" sz="900" dirty="0"/>
           </a:p>
           <a:p>
-            <a:pPr marL="0" indent="0" algn="l">
-              <a:buNone/>
-            </a:pPr>
-            <a:r>
-              <a:rPr sz="1100" b="1">
+            <a:pPr marL="228600" indent="-228600" algn="l">
+              <a:buFont typeface="+mj-lt"/>
+              <a:buAutoNum type="arabicPeriod"/>
+            </a:pPr>
+            <a:r>
+              <a:rPr lang="en-US" sz="1100" b="1" dirty="0">
                 <a:solidFill>
                   <a:srgbClr val="2A2A38"/>
                 </a:solidFill>
                 <a:latin typeface="Calibri"/>
               </a:rPr>
-              <a:t>DualQ Quantum Research &amp; Engineering Team</a:t>
-            </a:r>
+              <a:t>Arun M Hikadi</a:t>
+            </a:r>
+          </a:p>
+          <a:p>
+            <a:pPr marL="228600" indent="-228600" algn="l">
+              <a:buFont typeface="+mj-lt"/>
+              <a:buAutoNum type="arabicPeriod"/>
+            </a:pPr>
+            <a:r>
+              <a:rPr lang="en-US" sz="1100" b="1" dirty="0">
+                <a:solidFill>
+                  <a:srgbClr val="2A2A38"/>
+                </a:solidFill>
+                <a:latin typeface="Calibri"/>
+              </a:rPr>
+              <a:t>Chaitra </a:t>
+            </a:r>
+            <a:r>
+              <a:rPr lang="en-US" sz="1100" b="1" dirty="0" err="1">
+                <a:solidFill>
+                  <a:srgbClr val="2A2A38"/>
+                </a:solidFill>
+                <a:latin typeface="Calibri"/>
+              </a:rPr>
+              <a:t>Bhavikatti</a:t>
+            </a:r>
+            <a:endParaRPr lang="en-US" sz="1100" b="1" dirty="0">
+              <a:solidFill>
+                <a:srgbClr val="2A2A38"/>
+              </a:solidFill>
+              <a:latin typeface="Calibri"/>
+            </a:endParaRPr>
+          </a:p>
+          <a:p>
+            <a:pPr marL="228600" indent="-228600" algn="l">
+              <a:buFont typeface="+mj-lt"/>
+              <a:buAutoNum type="arabicPeriod"/>
+            </a:pPr>
             <a:endParaRPr lang="en-US" sz="900" dirty="0"/>
           </a:p>
         </p:txBody>
@@ -3609,7 +3707,7 @@
               <a:buNone/>
             </a:pPr>
             <a:r>
-              <a:rPr sz="1100" b="1">
+              <a:rPr sz="1100" b="1" dirty="0">
                 <a:solidFill>
                   <a:srgbClr val="2A2A38"/>
                 </a:solidFill>
@@ -3851,7 +3949,7 @@
         <p:spPr>
           <a:xfrm>
             <a:off x="457200" y="3291840"/>
-            <a:ext cx="2286000" cy="530352"/>
+            <a:ext cx="3415990" cy="530352"/>
           </a:xfrm>
           <a:prstGeom prst="roundRect">
             <a:avLst>
@@ -3892,13 +3990,24 @@
               <a:buNone/>
             </a:pPr>
             <a:r>
-              <a:rPr sz="1100" b="1">
+              <a:rPr sz="1100" b="1" dirty="0">
                 <a:solidFill>
                   <a:srgbClr val="2A2A38"/>
                 </a:solidFill>
                 <a:latin typeface="Calibri"/>
-              </a:rPr>
-              <a:t>github.com/vtu-qiskit-fall-fest-2026/vtu-hc-dualq.git</a:t>
+                <a:hlinkClick r:id="rId3" action="ppaction://hlinkfile"/>
+              </a:rPr>
+              <a:t>github.com/vtu-qiskit-fall-fest-2026/</a:t>
+            </a:r>
+            <a:r>
+              <a:rPr sz="1100" b="1" dirty="0" err="1">
+                <a:solidFill>
+                  <a:srgbClr val="2A2A38"/>
+                </a:solidFill>
+                <a:latin typeface="Calibri"/>
+                <a:hlinkClick r:id="rId3" action="ppaction://hlinkfile"/>
+              </a:rPr>
+              <a:t>vtu-hc-dualq.git</a:t>
             </a:r>
             <a:endParaRPr lang="en-US" sz="900" dirty="0"/>
           </a:p>
@@ -3912,8 +4021,8 @@
         </p:nvSpPr>
         <p:spPr>
           <a:xfrm>
-            <a:off x="2834640" y="3291840"/>
-            <a:ext cx="2286000" cy="530352"/>
+            <a:off x="2057400" y="3954780"/>
+            <a:ext cx="2697480" cy="530352"/>
           </a:xfrm>
           <a:prstGeom prst="roundRect">
             <a:avLst>
@@ -3933,9 +4042,6 @@
           <a:bodyPr wrap="square" lIns="63500" tIns="114300" rIns="114300" bIns="38100" rtlCol="0" anchor="t"/>
           <a:lstStyle/>
           <a:p>
-            <a:pPr marL="0" indent="0" algn="l">
-              <a:buNone/>
-            </a:pPr>
             <a:r>
               <a:rPr lang="en-US" sz="900" b="1" kern="0" spc="100" dirty="0">
                 <a:solidFill>
@@ -3945,22 +4051,16 @@
                 <a:ea typeface="Calibri" pitchFamily="34" charset="-122"/>
                 <a:cs typeface="Calibri" pitchFamily="34" charset="-120"/>
               </a:rPr>
-              <a:t>DEMO VIDEO LINK</a:t>
+              <a:t>DRIVE LINK</a:t>
             </a:r>
             <a:endParaRPr lang="en-US" sz="900" dirty="0"/>
           </a:p>
           <a:p>
-            <a:pPr marL="0" indent="0" algn="l">
-              <a:buNone/>
-            </a:pPr>
-            <a:r>
-              <a:rPr sz="1100" b="1">
-                <a:solidFill>
-                  <a:srgbClr val="2A2A38"/>
-                </a:solidFill>
-                <a:latin typeface="Calibri"/>
-              </a:rPr>
-              <a:t>results/dualq_demo_player.html (Silent Walkthrough)</a:t>
+            <a:r>
+              <a:rPr lang="en-IN" sz="900" dirty="0">
+                <a:hlinkClick r:id="rId4"/>
+              </a:rPr>
+              <a:t>https://drive.google.com/file/d/1lbJ0yZ_c1no-Mmnh5zP0uqF2bva68Foe/view?usp=vids_web</a:t>
             </a:r>
             <a:endParaRPr lang="en-US" sz="900" dirty="0"/>
           </a:p>
@@ -3975,7 +4075,7 @@
           <p:nvPr/>
         </p:nvPicPr>
         <p:blipFill>
-          <a:blip r:embed="rId3"/>
+          <a:blip r:embed="rId5"/>
           <a:stretch>
             <a:fillRect/>
           </a:stretch>
@@ -3999,7 +4099,7 @@
           <p:nvPr/>
         </p:nvPicPr>
         <p:blipFill>
-          <a:blip r:embed="rId4"/>
+          <a:blip r:embed="rId6"/>
           <a:stretch>
             <a:fillRect/>
           </a:stretch>
@@ -4023,7 +4123,7 @@
           <p:nvPr/>
         </p:nvPicPr>
         <p:blipFill>
-          <a:blip r:embed="rId5"/>
+          <a:blip r:embed="rId7"/>
           <a:stretch>
             <a:fillRect/>
           </a:stretch>
@@ -4047,7 +4147,7 @@
           <p:nvPr/>
         </p:nvPicPr>
         <p:blipFill>
-          <a:blip r:embed="rId6"/>
+          <a:blip r:embed="rId8"/>
           <a:stretch>
             <a:fillRect/>
           </a:stretch>
@@ -4154,6 +4254,13 @@
             <a:prstDash val="solid"/>
           </a:ln>
         </p:spPr>
+        <p:txBody>
+          <a:bodyPr/>
+          <a:lstStyle/>
+          <a:p>
+            <a:endParaRPr lang="en-IN"/>
+          </a:p>
+        </p:txBody>
       </p:sp>
       <p:sp>
         <p:nvSpPr>
@@ -4179,6 +4286,13 @@
             <a:prstDash val="solid"/>
           </a:ln>
         </p:spPr>
+        <p:txBody>
+          <a:bodyPr/>
+          <a:lstStyle/>
+          <a:p>
+            <a:endParaRPr lang="en-IN"/>
+          </a:p>
+        </p:txBody>
       </p:sp>
       <p:sp>
         <p:nvSpPr>
@@ -4204,6 +4318,13 @@
             <a:prstDash val="solid"/>
           </a:ln>
         </p:spPr>
+        <p:txBody>
+          <a:bodyPr/>
+          <a:lstStyle/>
+          <a:p>
+            <a:endParaRPr lang="en-IN"/>
+          </a:p>
+        </p:txBody>
       </p:sp>
       <p:sp>
         <p:nvSpPr>
@@ -4231,6 +4352,13 @@
             <a:prstDash val="solid"/>
           </a:ln>
         </p:spPr>
+        <p:txBody>
+          <a:bodyPr/>
+          <a:lstStyle/>
+          <a:p>
+            <a:endParaRPr lang="en-IN"/>
+          </a:p>
+        </p:txBody>
       </p:sp>
       <p:sp>
         <p:nvSpPr>
@@ -4256,6 +4384,13 @@
             <a:prstDash val="solid"/>
           </a:ln>
         </p:spPr>
+        <p:txBody>
+          <a:bodyPr/>
+          <a:lstStyle/>
+          <a:p>
+            <a:endParaRPr lang="en-IN"/>
+          </a:p>
+        </p:txBody>
       </p:sp>
       <p:sp>
         <p:nvSpPr>
@@ -4417,7 +4552,7 @@
           </a:prstGeom>
           <a:extLst>
             <a:ext uri="{C572A759-6A51-4108-AA02-DFA0A04FC94B}">
-              <ma14:wrappingTextBoxFlag xmlns:ma14="http://schemas.microsoft.com/office/mac/drawingml/2011/main" xmlns="" val="0"/>
+              <ma14:wrappingTextBoxFlag xmlns="" xmlns:ma14="http://schemas.microsoft.com/office/mac/drawingml/2011/main" val="0"/>
             </a:ext>
           </a:extLst>
         </p:spPr>
@@ -4534,6 +4669,13 @@
             <a:prstDash val="solid"/>
           </a:ln>
         </p:spPr>
+        <p:txBody>
+          <a:bodyPr/>
+          <a:lstStyle/>
+          <a:p>
+            <a:endParaRPr lang="en-IN"/>
+          </a:p>
+        </p:txBody>
       </p:sp>
       <p:sp>
         <p:nvSpPr>
@@ -4559,6 +4701,13 @@
             <a:prstDash val="solid"/>
           </a:ln>
         </p:spPr>
+        <p:txBody>
+          <a:bodyPr/>
+          <a:lstStyle/>
+          <a:p>
+            <a:endParaRPr lang="en-IN"/>
+          </a:p>
+        </p:txBody>
       </p:sp>
       <p:sp>
         <p:nvSpPr>
@@ -4584,6 +4733,13 @@
             <a:prstDash val="solid"/>
           </a:ln>
         </p:spPr>
+        <p:txBody>
+          <a:bodyPr/>
+          <a:lstStyle/>
+          <a:p>
+            <a:endParaRPr lang="en-IN"/>
+          </a:p>
+        </p:txBody>
       </p:sp>
       <p:sp>
         <p:nvSpPr>
@@ -4611,6 +4767,13 @@
             <a:prstDash val="solid"/>
           </a:ln>
         </p:spPr>
+        <p:txBody>
+          <a:bodyPr/>
+          <a:lstStyle/>
+          <a:p>
+            <a:endParaRPr lang="en-IN"/>
+          </a:p>
+        </p:txBody>
       </p:sp>
       <p:sp>
         <p:nvSpPr>
@@ -4636,6 +4799,13 @@
             <a:prstDash val="solid"/>
           </a:ln>
         </p:spPr>
+        <p:txBody>
+          <a:bodyPr/>
+          <a:lstStyle/>
+          <a:p>
+            <a:endParaRPr lang="en-IN"/>
+          </a:p>
+        </p:txBody>
       </p:sp>
       <p:sp>
         <p:nvSpPr>
@@ -4825,7 +4995,7 @@
           </a:prstGeom>
           <a:extLst>
             <a:ext uri="{C572A759-6A51-4108-AA02-DFA0A04FC94B}">
-              <ma14:wrappingTextBoxFlag xmlns:ma14="http://schemas.microsoft.com/office/mac/drawingml/2011/main" xmlns="" val="0"/>
+              <ma14:wrappingTextBoxFlag xmlns="" xmlns:ma14="http://schemas.microsoft.com/office/mac/drawingml/2011/main" val="0"/>
             </a:ext>
           </a:extLst>
         </p:spPr>
@@ -4942,6 +5112,13 @@
             <a:prstDash val="solid"/>
           </a:ln>
         </p:spPr>
+        <p:txBody>
+          <a:bodyPr/>
+          <a:lstStyle/>
+          <a:p>
+            <a:endParaRPr lang="en-IN"/>
+          </a:p>
+        </p:txBody>
       </p:sp>
       <p:sp>
         <p:nvSpPr>
@@ -4967,6 +5144,13 @@
             <a:prstDash val="solid"/>
           </a:ln>
         </p:spPr>
+        <p:txBody>
+          <a:bodyPr/>
+          <a:lstStyle/>
+          <a:p>
+            <a:endParaRPr lang="en-IN"/>
+          </a:p>
+        </p:txBody>
       </p:sp>
       <p:sp>
         <p:nvSpPr>
@@ -4992,6 +5176,13 @@
             <a:prstDash val="solid"/>
           </a:ln>
         </p:spPr>
+        <p:txBody>
+          <a:bodyPr/>
+          <a:lstStyle/>
+          <a:p>
+            <a:endParaRPr lang="en-IN"/>
+          </a:p>
+        </p:txBody>
       </p:sp>
       <p:sp>
         <p:nvSpPr>
@@ -5019,6 +5210,13 @@
             <a:prstDash val="solid"/>
           </a:ln>
         </p:spPr>
+        <p:txBody>
+          <a:bodyPr/>
+          <a:lstStyle/>
+          <a:p>
+            <a:endParaRPr lang="en-IN"/>
+          </a:p>
+        </p:txBody>
       </p:sp>
       <p:sp>
         <p:nvSpPr>
@@ -5044,6 +5242,13 @@
             <a:prstDash val="solid"/>
           </a:ln>
         </p:spPr>
+        <p:txBody>
+          <a:bodyPr/>
+          <a:lstStyle/>
+          <a:p>
+            <a:endParaRPr lang="en-IN"/>
+          </a:p>
+        </p:txBody>
       </p:sp>
       <p:sp>
         <p:nvSpPr>
@@ -5206,7 +5411,7 @@
           </a:prstGeom>
           <a:extLst>
             <a:ext uri="{C572A759-6A51-4108-AA02-DFA0A04FC94B}">
-              <ma14:wrappingTextBoxFlag xmlns:ma14="http://schemas.microsoft.com/office/mac/drawingml/2011/main" xmlns="" val="0"/>
+              <ma14:wrappingTextBoxFlag xmlns="" xmlns:ma14="http://schemas.microsoft.com/office/mac/drawingml/2011/main" val="0"/>
             </a:ext>
           </a:extLst>
         </p:spPr>
@@ -5323,6 +5528,13 @@
             <a:prstDash val="solid"/>
           </a:ln>
         </p:spPr>
+        <p:txBody>
+          <a:bodyPr/>
+          <a:lstStyle/>
+          <a:p>
+            <a:endParaRPr lang="en-IN"/>
+          </a:p>
+        </p:txBody>
       </p:sp>
       <p:sp>
         <p:nvSpPr>
@@ -5348,6 +5560,13 @@
             <a:prstDash val="solid"/>
           </a:ln>
         </p:spPr>
+        <p:txBody>
+          <a:bodyPr/>
+          <a:lstStyle/>
+          <a:p>
+            <a:endParaRPr lang="en-IN"/>
+          </a:p>
+        </p:txBody>
       </p:sp>
       <p:sp>
         <p:nvSpPr>
@@ -5373,6 +5592,13 @@
             <a:prstDash val="solid"/>
           </a:ln>
         </p:spPr>
+        <p:txBody>
+          <a:bodyPr/>
+          <a:lstStyle/>
+          <a:p>
+            <a:endParaRPr lang="en-IN"/>
+          </a:p>
+        </p:txBody>
       </p:sp>
       <p:sp>
         <p:nvSpPr>
@@ -5400,6 +5626,13 @@
             <a:prstDash val="dash"/>
           </a:ln>
         </p:spPr>
+        <p:txBody>
+          <a:bodyPr/>
+          <a:lstStyle/>
+          <a:p>
+            <a:endParaRPr lang="en-IN"/>
+          </a:p>
+        </p:txBody>
       </p:sp>
       <p:sp>
         <p:nvSpPr>
@@ -5455,6 +5688,13 @@
             <a:prstDash val="solid"/>
           </a:ln>
         </p:spPr>
+        <p:txBody>
+          <a:bodyPr/>
+          <a:lstStyle/>
+          <a:p>
+            <a:endParaRPr lang="en-IN"/>
+          </a:p>
+        </p:txBody>
       </p:sp>
       <p:sp>
         <p:nvSpPr>
@@ -5480,6 +5720,13 @@
             <a:prstDash val="solid"/>
           </a:ln>
         </p:spPr>
+        <p:txBody>
+          <a:bodyPr/>
+          <a:lstStyle/>
+          <a:p>
+            <a:endParaRPr lang="en-IN"/>
+          </a:p>
+        </p:txBody>
       </p:sp>
       <p:sp>
         <p:nvSpPr>
@@ -5517,7 +5764,7 @@
               </a:spcAft>
             </a:pPr>
             <a:r>
-              <a:rPr sz="1050" b="1">
+              <a:rPr sz="1050" b="1" dirty="0">
                 <a:solidFill>
                   <a:srgbClr val="2E1B5B"/>
                 </a:solidFill>
@@ -5526,13 +5773,31 @@
               <a:t>Feature Map Architecture:  </a:t>
             </a:r>
             <a:r>
-              <a:rPr sz="1050" b="0">
+              <a:rPr sz="1050" b="0" dirty="0">
                 <a:solidFill>
                   <a:srgbClr val="2A2A38"/>
                 </a:solidFill>
                 <a:latin typeface="Calibri"/>
               </a:rPr>
-              <a:t>4-Qubit Second-Order ZZFeatureMap (reps=1, linear entanglement topology).</a:t>
+              <a:t>4-Qubit Second-Order </a:t>
+            </a:r>
+            <a:r>
+              <a:rPr sz="1050" b="0" dirty="0" err="1">
+                <a:solidFill>
+                  <a:srgbClr val="2A2A38"/>
+                </a:solidFill>
+                <a:latin typeface="Calibri"/>
+              </a:rPr>
+              <a:t>ZZFeatureMap</a:t>
+            </a:r>
+            <a:r>
+              <a:rPr sz="1050" b="0" dirty="0">
+                <a:solidFill>
+                  <a:srgbClr val="2A2A38"/>
+                </a:solidFill>
+                <a:latin typeface="Calibri"/>
+              </a:rPr>
+              <a:t> (reps=1, linear entanglement topology).</a:t>
             </a:r>
           </a:p>
           <a:p>
@@ -5545,7 +5810,7 @@
               </a:spcAft>
             </a:pPr>
             <a:r>
-              <a:rPr sz="1050" b="1">
+              <a:rPr sz="1050" b="1" dirty="0">
                 <a:solidFill>
                   <a:srgbClr val="2E1B5B"/>
                 </a:solidFill>
@@ -5554,7 +5819,7 @@
               <a:t>Encoding Quantum Gates:  </a:t>
             </a:r>
             <a:r>
-              <a:rPr sz="1050" b="0">
+              <a:rPr sz="1050" b="0" dirty="0">
                 <a:solidFill>
                   <a:srgbClr val="2A2A38"/>
                 </a:solidFill>
@@ -5575,7 +5840,7 @@
               </a:spcAft>
             </a:pPr>
             <a:r>
-              <a:rPr sz="1050" b="1">
+              <a:rPr sz="1050" b="1" dirty="0">
                 <a:solidFill>
                   <a:srgbClr val="2E1B5B"/>
                 </a:solidFill>
@@ -5584,7 +5849,7 @@
               <a:t>Quantum Circuit Metrics:  </a:t>
             </a:r>
             <a:r>
-              <a:rPr sz="1050" b="0">
+              <a:rPr sz="1050" b="0" dirty="0">
                 <a:solidFill>
                   <a:srgbClr val="2A2A38"/>
                 </a:solidFill>
@@ -5592,36 +5857,35 @@
               </a:rPr>
               <a:t>• 4 Active Qubits (q₀ - q₃)
 • 8 Single-Qubit Rotations
-• 6 Two-Qubit CNOT Gates
-• Circuit Depth: 11 (unrolled)</a:t>
-            </a:r>
-          </a:p>
-          <a:p>
-            <a:pPr>
-              <a:lnSpc>
-                <a:spcPct val="115000"/>
-              </a:lnSpc>
-              <a:spcAft>
-                <a:spcPts val="500"/>
-              </a:spcAft>
-            </a:pPr>
-            <a:r>
-              <a:rPr sz="1050" b="1">
-                <a:solidFill>
-                  <a:srgbClr val="2E1B5B"/>
+• 6 Two-Qubit CNOT Ga</a:t>
+            </a:r>
+            <a:r>
+              <a:rPr lang="en-IN" sz="1050" b="0" dirty="0" err="1">
+                <a:solidFill>
+                  <a:srgbClr val="2A2A38"/>
                 </a:solidFill>
                 <a:latin typeface="Calibri"/>
               </a:rPr>
-              <a:t>Noise Mitigation:  </a:t>
-            </a:r>
-            <a:r>
-              <a:rPr sz="1050" b="0">
+              <a:t>tes</a:t>
+            </a:r>
+            <a:r>
+              <a:rPr lang="en-IN" sz="1050" b="0" dirty="0">
                 <a:solidFill>
                   <a:srgbClr val="2A2A38"/>
                 </a:solidFill>
                 <a:latin typeface="Calibri"/>
               </a:rPr>
-              <a:t>Virtual QPU models T₁/T₂ relaxation with automated M⁻¹ readout mitigation.</a:t>
+              <a:t>
+</a:t>
+            </a:r>
+            <a:r>
+              <a:rPr lang="en-US" sz="1050" b="0" dirty="0">
+                <a:solidFill>
+                  <a:srgbClr val="2A2A38"/>
+                </a:solidFill>
+                <a:latin typeface="Calibri"/>
+              </a:rPr>
+              <a:t>.</a:t>
             </a:r>
           </a:p>
         </p:txBody>
@@ -5646,7 +5910,7 @@
           </a:prstGeom>
           <a:extLst>
             <a:ext uri="{C572A759-6A51-4108-AA02-DFA0A04FC94B}">
-              <ma14:wrappingTextBoxFlag xmlns:ma14="http://schemas.microsoft.com/office/mac/drawingml/2011/main" xmlns="" val="0"/>
+              <ma14:wrappingTextBoxFlag xmlns="" xmlns:ma14="http://schemas.microsoft.com/office/mac/drawingml/2011/main" val="0"/>
             </a:ext>
           </a:extLst>
         </p:spPr>
@@ -5787,6 +6051,13 @@
             <a:prstDash val="solid"/>
           </a:ln>
         </p:spPr>
+        <p:txBody>
+          <a:bodyPr/>
+          <a:lstStyle/>
+          <a:p>
+            <a:endParaRPr lang="en-IN"/>
+          </a:p>
+        </p:txBody>
       </p:sp>
       <p:sp>
         <p:nvSpPr>
@@ -5812,6 +6083,13 @@
             <a:prstDash val="solid"/>
           </a:ln>
         </p:spPr>
+        <p:txBody>
+          <a:bodyPr/>
+          <a:lstStyle/>
+          <a:p>
+            <a:endParaRPr lang="en-IN"/>
+          </a:p>
+        </p:txBody>
       </p:sp>
       <p:sp>
         <p:nvSpPr>
@@ -5837,6 +6115,13 @@
             <a:prstDash val="solid"/>
           </a:ln>
         </p:spPr>
+        <p:txBody>
+          <a:bodyPr/>
+          <a:lstStyle/>
+          <a:p>
+            <a:endParaRPr lang="en-IN"/>
+          </a:p>
+        </p:txBody>
       </p:sp>
       <p:sp>
         <p:nvSpPr>
@@ -5864,6 +6149,13 @@
             <a:prstDash val="solid"/>
           </a:ln>
         </p:spPr>
+        <p:txBody>
+          <a:bodyPr/>
+          <a:lstStyle/>
+          <a:p>
+            <a:endParaRPr lang="en-IN"/>
+          </a:p>
+        </p:txBody>
       </p:sp>
       <p:sp>
         <p:nvSpPr>
@@ -5889,6 +6181,13 @@
             <a:prstDash val="solid"/>
           </a:ln>
         </p:spPr>
+        <p:txBody>
+          <a:bodyPr/>
+          <a:lstStyle/>
+          <a:p>
+            <a:endParaRPr lang="en-IN"/>
+          </a:p>
+        </p:txBody>
       </p:sp>
       <p:sp>
         <p:nvSpPr>
@@ -6050,7 +6349,7 @@
           </a:prstGeom>
           <a:extLst>
             <a:ext uri="{C572A759-6A51-4108-AA02-DFA0A04FC94B}">
-              <ma14:wrappingTextBoxFlag xmlns:ma14="http://schemas.microsoft.com/office/mac/drawingml/2011/main" xmlns="" val="0"/>
+              <ma14:wrappingTextBoxFlag xmlns="" xmlns:ma14="http://schemas.microsoft.com/office/mac/drawingml/2011/main" val="0"/>
             </a:ext>
           </a:extLst>
         </p:spPr>
@@ -6167,6 +6466,13 @@
             <a:prstDash val="solid"/>
           </a:ln>
         </p:spPr>
+        <p:txBody>
+          <a:bodyPr/>
+          <a:lstStyle/>
+          <a:p>
+            <a:endParaRPr lang="en-IN"/>
+          </a:p>
+        </p:txBody>
       </p:sp>
       <p:sp>
         <p:nvSpPr>
@@ -6192,6 +6498,13 @@
             <a:prstDash val="solid"/>
           </a:ln>
         </p:spPr>
+        <p:txBody>
+          <a:bodyPr/>
+          <a:lstStyle/>
+          <a:p>
+            <a:endParaRPr lang="en-IN"/>
+          </a:p>
+        </p:txBody>
       </p:sp>
       <p:sp>
         <p:nvSpPr>
@@ -6217,6 +6530,13 @@
             <a:prstDash val="solid"/>
           </a:ln>
         </p:spPr>
+        <p:txBody>
+          <a:bodyPr/>
+          <a:lstStyle/>
+          <a:p>
+            <a:endParaRPr lang="en-IN"/>
+          </a:p>
+        </p:txBody>
       </p:sp>
       <p:sp>
         <p:nvSpPr>
@@ -6244,6 +6564,13 @@
             <a:prstDash val="dash"/>
           </a:ln>
         </p:spPr>
+        <p:txBody>
+          <a:bodyPr/>
+          <a:lstStyle/>
+          <a:p>
+            <a:endParaRPr lang="en-IN"/>
+          </a:p>
+        </p:txBody>
       </p:sp>
       <p:sp>
         <p:nvSpPr>
@@ -6281,7 +6608,7 @@
         </p:nvSpPr>
         <p:spPr>
           <a:xfrm>
-            <a:off x="5577840" y="1691640"/>
+            <a:off x="5620520" y="1746504"/>
             <a:ext cx="3108960" cy="2926080"/>
           </a:xfrm>
           <a:prstGeom prst="roundRect">
@@ -6299,6 +6626,13 @@
             <a:prstDash val="solid"/>
           </a:ln>
         </p:spPr>
+        <p:txBody>
+          <a:bodyPr/>
+          <a:lstStyle/>
+          <a:p>
+            <a:endParaRPr lang="en-IN"/>
+          </a:p>
+        </p:txBody>
       </p:sp>
       <p:sp>
         <p:nvSpPr>
@@ -6324,6 +6658,13 @@
             <a:prstDash val="solid"/>
           </a:ln>
         </p:spPr>
+        <p:txBody>
+          <a:bodyPr/>
+          <a:lstStyle/>
+          <a:p>
+            <a:endParaRPr lang="en-IN"/>
+          </a:p>
+        </p:txBody>
       </p:sp>
       <p:sp>
         <p:nvSpPr>
@@ -6333,8 +6674,8 @@
         </p:nvSpPr>
         <p:spPr>
           <a:xfrm>
-            <a:off x="5750000" y="1800000"/>
-            <a:ext cx="2850000" cy="2700000"/>
+            <a:off x="5707260" y="1967896"/>
+            <a:ext cx="2935480" cy="2373567"/>
           </a:xfrm>
           <a:prstGeom prst="rect">
             <a:avLst/>
@@ -6349,7 +6690,7 @@
             <a:pPr marL="0" indent="0">
               <a:buNone/>
             </a:pPr>
-            <a:endParaRPr lang="en-US" sz="1200" dirty="0"/>
+            <a:endParaRPr lang="en-US" sz="800" dirty="0"/>
           </a:p>
           <a:p>
             <a:pPr>
@@ -6361,7 +6702,7 @@
               </a:spcAft>
             </a:pPr>
             <a:r>
-              <a:rPr sz="1050" b="1">
+              <a:rPr sz="800" b="1" dirty="0">
                 <a:solidFill>
                   <a:srgbClr val="2E1B5B"/>
                 </a:solidFill>
@@ -6370,7 +6711,7 @@
               <a:t>Trainable KTA Quantum Kernel:  </a:t>
             </a:r>
             <a:r>
-              <a:rPr sz="1050" b="0">
+              <a:rPr sz="800" b="0" dirty="0">
                 <a:solidFill>
                   <a:srgbClr val="2A2A38"/>
                 </a:solidFill>
@@ -6390,16 +6731,43 @@
               </a:spcAft>
             </a:pPr>
             <a:r>
-              <a:rPr sz="1050" b="1">
+              <a:rPr sz="800" b="1" dirty="0" err="1">
                 <a:solidFill>
                   <a:srgbClr val="2E1B5B"/>
                 </a:solidFill>
                 <a:latin typeface="Calibri"/>
               </a:rPr>
-              <a:t>Pegasos QSVC (Subgradient):  </a:t>
-            </a:r>
-            <a:r>
-              <a:rPr sz="1050" b="0">
+              <a:t>Pegasos</a:t>
+            </a:r>
+            <a:r>
+              <a:rPr sz="800" b="1" dirty="0">
+                <a:solidFill>
+                  <a:srgbClr val="2E1B5B"/>
+                </a:solidFill>
+                <a:latin typeface="Calibri"/>
+              </a:rPr>
+              <a:t> QSVC (</a:t>
+            </a:r>
+            <a:r>
+              <a:rPr sz="800" b="1" dirty="0" err="1">
+                <a:solidFill>
+                  <a:srgbClr val="2E1B5B"/>
+                </a:solidFill>
+                <a:latin typeface="Calibri"/>
+              </a:rPr>
+              <a:t>Subgradient</a:t>
+            </a:r>
+            <a:r>
+              <a:rPr sz="800" b="1" dirty="0">
+                <a:solidFill>
+                  <a:srgbClr val="2E1B5B"/>
+                </a:solidFill>
+                <a:latin typeface="Calibri"/>
+              </a:rPr>
+              <a:t>):  </a:t>
+            </a:r>
+            <a:r>
+              <a:rPr sz="800" b="0" dirty="0">
                 <a:solidFill>
                   <a:srgbClr val="2A2A38"/>
                 </a:solidFill>
@@ -6420,7 +6788,7 @@
               </a:spcAft>
             </a:pPr>
             <a:r>
-              <a:rPr sz="1050" b="1">
+              <a:rPr sz="800" b="1" dirty="0">
                 <a:solidFill>
                   <a:srgbClr val="2E1B5B"/>
                 </a:solidFill>
@@ -6429,14 +6797,37 @@
               <a:t>Class Imbalance Mitigation:  </a:t>
             </a:r>
             <a:r>
-              <a:rPr sz="1050" b="0">
+              <a:rPr sz="800" b="0" dirty="0">
                 <a:solidFill>
                   <a:srgbClr val="2A2A38"/>
                 </a:solidFill>
                 <a:latin typeface="Calibri"/>
               </a:rPr>
-              <a:t>• SMOTE quantum resampling elevates minority fraud recall to 50.0%.
-• Projected kernels (PQK) eliminate barren plateaus.</a:t>
+              <a:t>• SMOTE quantum resampling elevates minority fraud recall to 50.0%</a:t>
+            </a:r>
+            <a:endParaRPr lang="en-US" sz="800" dirty="0">
+              <a:solidFill>
+                <a:srgbClr val="2A2A38"/>
+              </a:solidFill>
+              <a:latin typeface="Calibri"/>
+            </a:endParaRPr>
+          </a:p>
+          <a:p>
+            <a:pPr>
+              <a:lnSpc>
+                <a:spcPct val="115000"/>
+              </a:lnSpc>
+              <a:spcAft>
+                <a:spcPts val="700"/>
+              </a:spcAft>
+            </a:pPr>
+            <a:r>
+              <a:rPr lang="en-IN" sz="800" dirty="0">
+                <a:solidFill>
+                  <a:srgbClr val="2A2A38"/>
+                </a:solidFill>
+              </a:rPr>
+              <a:t>• Projected kernels (PQK) eliminate barren plateaus.</a:t>
             </a:r>
           </a:p>
           <a:p>
@@ -6449,22 +6840,40 @@
               </a:spcAft>
             </a:pPr>
             <a:r>
-              <a:rPr sz="1050" b="1">
+              <a:rPr lang="en-IN" sz="800" b="1" dirty="0">
                 <a:solidFill>
                   <a:srgbClr val="2E1B5B"/>
                 </a:solidFill>
+              </a:rPr>
+              <a:t>Gram Matrix Analysis:  </a:t>
+            </a:r>
+            <a:r>
+              <a:rPr lang="en-IN" sz="800" dirty="0">
+                <a:solidFill>
+                  <a:srgbClr val="2A2A38"/>
+                </a:solidFill>
+              </a:rPr>
+              <a:t>Projected kernels display rich off-diagonal structure, enabling robust decision boundaries.</a:t>
+            </a:r>
+          </a:p>
+          <a:p>
+            <a:pPr>
+              <a:lnSpc>
+                <a:spcPct val="115000"/>
+              </a:lnSpc>
+              <a:spcAft>
+                <a:spcPts val="700"/>
+              </a:spcAft>
+            </a:pPr>
+            <a:r>
+              <a:rPr sz="800" b="0" dirty="0">
+                <a:solidFill>
+                  <a:srgbClr val="2A2A38"/>
+                </a:solidFill>
                 <a:latin typeface="Calibri"/>
               </a:rPr>
-              <a:t>Gram Matrix Analysis:  </a:t>
-            </a:r>
-            <a:r>
-              <a:rPr sz="1050" b="0">
-                <a:solidFill>
-                  <a:srgbClr val="2A2A38"/>
-                </a:solidFill>
-                <a:latin typeface="Calibri"/>
-              </a:rPr>
-              <a:t>Projected kernels display rich off-diagonal structure, enabling robust decision boundaries.</a:t>
+              <a:t>
+</a:t>
             </a:r>
           </a:p>
         </p:txBody>
@@ -6489,7 +6898,7 @@
           </a:prstGeom>
           <a:extLst>
             <a:ext uri="{C572A759-6A51-4108-AA02-DFA0A04FC94B}">
-              <ma14:wrappingTextBoxFlag xmlns:ma14="http://schemas.microsoft.com/office/mac/drawingml/2011/main" xmlns="" val="0"/>
+              <ma14:wrappingTextBoxFlag xmlns="" xmlns:ma14="http://schemas.microsoft.com/office/mac/drawingml/2011/main" val="0"/>
             </a:ext>
           </a:extLst>
         </p:spPr>
@@ -6630,6 +7039,13 @@
             <a:prstDash val="solid"/>
           </a:ln>
         </p:spPr>
+        <p:txBody>
+          <a:bodyPr/>
+          <a:lstStyle/>
+          <a:p>
+            <a:endParaRPr lang="en-IN"/>
+          </a:p>
+        </p:txBody>
       </p:sp>
       <p:sp>
         <p:nvSpPr>
@@ -6655,6 +7071,13 @@
             <a:prstDash val="solid"/>
           </a:ln>
         </p:spPr>
+        <p:txBody>
+          <a:bodyPr/>
+          <a:lstStyle/>
+          <a:p>
+            <a:endParaRPr lang="en-IN"/>
+          </a:p>
+        </p:txBody>
       </p:sp>
       <p:sp>
         <p:nvSpPr>
@@ -6680,6 +7103,13 @@
             <a:prstDash val="solid"/>
           </a:ln>
         </p:spPr>
+        <p:txBody>
+          <a:bodyPr/>
+          <a:lstStyle/>
+          <a:p>
+            <a:endParaRPr lang="en-IN"/>
+          </a:p>
+        </p:txBody>
       </p:sp>
       <p:sp>
         <p:nvSpPr>
@@ -6707,6 +7137,13 @@
             <a:prstDash val="solid"/>
           </a:ln>
         </p:spPr>
+        <p:txBody>
+          <a:bodyPr/>
+          <a:lstStyle/>
+          <a:p>
+            <a:endParaRPr lang="en-IN"/>
+          </a:p>
+        </p:txBody>
       </p:sp>
       <p:sp>
         <p:nvSpPr>
@@ -6732,6 +7169,13 @@
             <a:prstDash val="solid"/>
           </a:ln>
         </p:spPr>
+        <p:txBody>
+          <a:bodyPr/>
+          <a:lstStyle/>
+          <a:p>
+            <a:endParaRPr lang="en-IN"/>
+          </a:p>
+        </p:txBody>
       </p:sp>
       <p:sp>
         <p:nvSpPr>
@@ -6893,7 +7337,7 @@
           </a:prstGeom>
           <a:extLst>
             <a:ext uri="{C572A759-6A51-4108-AA02-DFA0A04FC94B}">
-              <ma14:wrappingTextBoxFlag xmlns:ma14="http://schemas.microsoft.com/office/mac/drawingml/2011/main" xmlns="" val="0"/>
+              <ma14:wrappingTextBoxFlag xmlns="" xmlns:ma14="http://schemas.microsoft.com/office/mac/drawingml/2011/main" val="0"/>
             </a:ext>
           </a:extLst>
         </p:spPr>
@@ -7010,6 +7454,13 @@
             <a:prstDash val="solid"/>
           </a:ln>
         </p:spPr>
+        <p:txBody>
+          <a:bodyPr/>
+          <a:lstStyle/>
+          <a:p>
+            <a:endParaRPr lang="en-IN"/>
+          </a:p>
+        </p:txBody>
       </p:sp>
       <p:sp>
         <p:nvSpPr>
@@ -7035,6 +7486,13 @@
             <a:prstDash val="solid"/>
           </a:ln>
         </p:spPr>
+        <p:txBody>
+          <a:bodyPr/>
+          <a:lstStyle/>
+          <a:p>
+            <a:endParaRPr lang="en-IN"/>
+          </a:p>
+        </p:txBody>
       </p:sp>
       <p:sp>
         <p:nvSpPr>
@@ -7060,6 +7518,13 @@
             <a:prstDash val="solid"/>
           </a:ln>
         </p:spPr>
+        <p:txBody>
+          <a:bodyPr/>
+          <a:lstStyle/>
+          <a:p>
+            <a:endParaRPr lang="en-IN"/>
+          </a:p>
+        </p:txBody>
       </p:sp>
       <p:sp>
         <p:nvSpPr>
@@ -7087,6 +7552,13 @@
             <a:prstDash val="solid"/>
           </a:ln>
         </p:spPr>
+        <p:txBody>
+          <a:bodyPr/>
+          <a:lstStyle/>
+          <a:p>
+            <a:endParaRPr lang="en-IN"/>
+          </a:p>
+        </p:txBody>
       </p:sp>
       <p:sp>
         <p:nvSpPr>
@@ -7112,6 +7584,13 @@
             <a:prstDash val="solid"/>
           </a:ln>
         </p:spPr>
+        <p:txBody>
+          <a:bodyPr/>
+          <a:lstStyle/>
+          <a:p>
+            <a:endParaRPr lang="en-IN"/>
+          </a:p>
+        </p:txBody>
       </p:sp>
       <p:sp>
         <p:nvSpPr>
@@ -7273,7 +7752,7 @@
           </a:prstGeom>
           <a:extLst>
             <a:ext uri="{C572A759-6A51-4108-AA02-DFA0A04FC94B}">
-              <ma14:wrappingTextBoxFlag xmlns:ma14="http://schemas.microsoft.com/office/mac/drawingml/2011/main" xmlns="" val="0"/>
+              <ma14:wrappingTextBoxFlag xmlns="" xmlns:ma14="http://schemas.microsoft.com/office/mac/drawingml/2011/main" val="0"/>
             </a:ext>
           </a:extLst>
         </p:spPr>

</xml_diff>